<commit_message>
Update slide 2 image
Made-with: Cursor
</commit_message>
<xml_diff>
--- a/proj demo.pptx
+++ b/proj demo.pptx
@@ -7,6 +7,7 @@
   <p:sldIdLst>
     <p:sldId id="256" r:id="rId2"/>
     <p:sldId id="257" r:id="rId3"/>
+    <p:sldId id="258" r:id="rId4"/>
   </p:sldIdLst>
   <p:sldSz cx="25992138" cy="12204700"/>
   <p:notesSz cx="6858000" cy="9144000"/>
@@ -105,6 +106,11 @@
       </a:defRPr>
     </a:lvl9pPr>
   </p:defaultTextStyle>
+  <p:extLst>
+    <p:ext uri="{EFAFB233-063F-42B5-8137-9DF3F51BA10A}">
+      <p15:sldGuideLst xmlns:p15="http://schemas.microsoft.com/office/powerpoint/2012/main"/>
+    </p:ext>
+  </p:extLst>
 </p:presentation>
 </file>
 
@@ -239,7 +245,7 @@
           <a:p>
             <a:fld id="{5A9D6236-42D1-6D41-98F7-ECB7216278C9}" type="datetimeFigureOut">
               <a:rPr kumimoji="1" lang="zh-CN" altLang="en-US" smtClean="0"/>
-              <a:t>2026/3/10</a:t>
+              <a:t>2026/3/11</a:t>
             </a:fld>
             <a:endParaRPr kumimoji="1" lang="zh-CN" altLang="en-US"/>
           </a:p>
@@ -409,7 +415,7 @@
           <a:p>
             <a:fld id="{5A9D6236-42D1-6D41-98F7-ECB7216278C9}" type="datetimeFigureOut">
               <a:rPr kumimoji="1" lang="zh-CN" altLang="en-US" smtClean="0"/>
-              <a:t>2026/3/10</a:t>
+              <a:t>2026/3/11</a:t>
             </a:fld>
             <a:endParaRPr kumimoji="1" lang="zh-CN" altLang="en-US"/>
           </a:p>
@@ -589,7 +595,7 @@
           <a:p>
             <a:fld id="{5A9D6236-42D1-6D41-98F7-ECB7216278C9}" type="datetimeFigureOut">
               <a:rPr kumimoji="1" lang="zh-CN" altLang="en-US" smtClean="0"/>
-              <a:t>2026/3/10</a:t>
+              <a:t>2026/3/11</a:t>
             </a:fld>
             <a:endParaRPr kumimoji="1" lang="zh-CN" altLang="en-US"/>
           </a:p>
@@ -759,7 +765,7 @@
           <a:p>
             <a:fld id="{5A9D6236-42D1-6D41-98F7-ECB7216278C9}" type="datetimeFigureOut">
               <a:rPr kumimoji="1" lang="zh-CN" altLang="en-US" smtClean="0"/>
-              <a:t>2026/3/10</a:t>
+              <a:t>2026/3/11</a:t>
             </a:fld>
             <a:endParaRPr kumimoji="1" lang="zh-CN" altLang="en-US"/>
           </a:p>
@@ -1005,7 +1011,7 @@
           <a:p>
             <a:fld id="{5A9D6236-42D1-6D41-98F7-ECB7216278C9}" type="datetimeFigureOut">
               <a:rPr kumimoji="1" lang="zh-CN" altLang="en-US" smtClean="0"/>
-              <a:t>2026/3/10</a:t>
+              <a:t>2026/3/11</a:t>
             </a:fld>
             <a:endParaRPr kumimoji="1" lang="zh-CN" altLang="en-US"/>
           </a:p>
@@ -1237,7 +1243,7 @@
           <a:p>
             <a:fld id="{5A9D6236-42D1-6D41-98F7-ECB7216278C9}" type="datetimeFigureOut">
               <a:rPr kumimoji="1" lang="zh-CN" altLang="en-US" smtClean="0"/>
-              <a:t>2026/3/10</a:t>
+              <a:t>2026/3/11</a:t>
             </a:fld>
             <a:endParaRPr kumimoji="1" lang="zh-CN" altLang="en-US"/>
           </a:p>
@@ -1604,7 +1610,7 @@
           <a:p>
             <a:fld id="{5A9D6236-42D1-6D41-98F7-ECB7216278C9}" type="datetimeFigureOut">
               <a:rPr kumimoji="1" lang="zh-CN" altLang="en-US" smtClean="0"/>
-              <a:t>2026/3/10</a:t>
+              <a:t>2026/3/11</a:t>
             </a:fld>
             <a:endParaRPr kumimoji="1" lang="zh-CN" altLang="en-US"/>
           </a:p>
@@ -1722,7 +1728,7 @@
           <a:p>
             <a:fld id="{5A9D6236-42D1-6D41-98F7-ECB7216278C9}" type="datetimeFigureOut">
               <a:rPr kumimoji="1" lang="zh-CN" altLang="en-US" smtClean="0"/>
-              <a:t>2026/3/10</a:t>
+              <a:t>2026/3/11</a:t>
             </a:fld>
             <a:endParaRPr kumimoji="1" lang="zh-CN" altLang="en-US"/>
           </a:p>
@@ -1817,7 +1823,7 @@
           <a:p>
             <a:fld id="{5A9D6236-42D1-6D41-98F7-ECB7216278C9}" type="datetimeFigureOut">
               <a:rPr kumimoji="1" lang="zh-CN" altLang="en-US" smtClean="0"/>
-              <a:t>2026/3/10</a:t>
+              <a:t>2026/3/11</a:t>
             </a:fld>
             <a:endParaRPr kumimoji="1" lang="zh-CN" altLang="en-US"/>
           </a:p>
@@ -2094,7 +2100,7 @@
           <a:p>
             <a:fld id="{5A9D6236-42D1-6D41-98F7-ECB7216278C9}" type="datetimeFigureOut">
               <a:rPr kumimoji="1" lang="zh-CN" altLang="en-US" smtClean="0"/>
-              <a:t>2026/3/10</a:t>
+              <a:t>2026/3/11</a:t>
             </a:fld>
             <a:endParaRPr kumimoji="1" lang="zh-CN" altLang="en-US"/>
           </a:p>
@@ -2351,7 +2357,7 @@
           <a:p>
             <a:fld id="{5A9D6236-42D1-6D41-98F7-ECB7216278C9}" type="datetimeFigureOut">
               <a:rPr kumimoji="1" lang="zh-CN" altLang="en-US" smtClean="0"/>
-              <a:t>2026/3/10</a:t>
+              <a:t>2026/3/11</a:t>
             </a:fld>
             <a:endParaRPr kumimoji="1" lang="zh-CN" altLang="en-US"/>
           </a:p>
@@ -2564,7 +2570,7 @@
           <a:p>
             <a:fld id="{5A9D6236-42D1-6D41-98F7-ECB7216278C9}" type="datetimeFigureOut">
               <a:rPr kumimoji="1" lang="zh-CN" altLang="en-US" smtClean="0"/>
-              <a:t>2026/3/10</a:t>
+              <a:t>2026/3/11</a:t>
             </a:fld>
             <a:endParaRPr kumimoji="1" lang="zh-CN" altLang="en-US"/>
           </a:p>
@@ -3553,58 +3559,36 @@
           </a:p>
         </p:txBody>
       </p:sp>
-      <p:sp>
-        <p:nvSpPr>
-          <p:cNvPr id="20" name="矩形 19">
+      <p:pic>
+        <p:nvPicPr>
+          <p:cNvPr id="21" name="图片 20" descr="图片包含 矩形&#10;&#10;描述已自动生成">
             <a:extLst>
               <a:ext uri="{FF2B5EF4-FFF2-40B4-BE49-F238E27FC236}">
-                <a16:creationId xmlns:a16="http://schemas.microsoft.com/office/drawing/2014/main" id="{21C9BD91-5204-AA68-EDCB-43D77DE92095}"/>
+                <a16:creationId xmlns:a16="http://schemas.microsoft.com/office/drawing/2014/main" id="{E47746B1-7C10-9913-C9E2-FF87F137D4A6}"/>
               </a:ext>
             </a:extLst>
           </p:cNvPr>
-          <p:cNvSpPr/>
+          <p:cNvPicPr>
+            <a:picLocks noChangeAspect="1"/>
+          </p:cNvPicPr>
           <p:nvPr/>
-        </p:nvSpPr>
-        <p:spPr>
-          <a:xfrm>
-            <a:off x="9620520" y="1455312"/>
-            <a:ext cx="6732670" cy="605307"/>
+        </p:nvPicPr>
+        <p:blipFill>
+          <a:blip r:embed="rId2"/>
+          <a:stretch>
+            <a:fillRect/>
+          </a:stretch>
+        </p:blipFill>
+        <p:spPr>
+          <a:xfrm>
+            <a:off x="16731173" y="-5633190"/>
+            <a:ext cx="9555811" cy="15941741"/>
           </a:xfrm>
           <a:prstGeom prst="rect">
             <a:avLst/>
           </a:prstGeom>
-          <a:solidFill>
-            <a:srgbClr val="1A1A1A"/>
-          </a:solidFill>
-          <a:ln>
-            <a:noFill/>
-          </a:ln>
-        </p:spPr>
-        <p:style>
-          <a:lnRef idx="2">
-            <a:schemeClr val="accent1">
-              <a:shade val="15000"/>
-            </a:schemeClr>
-          </a:lnRef>
-          <a:fillRef idx="1">
-            <a:schemeClr val="accent1"/>
-          </a:fillRef>
-          <a:effectRef idx="0">
-            <a:schemeClr val="accent1"/>
-          </a:effectRef>
-          <a:fontRef idx="minor">
-            <a:schemeClr val="lt1"/>
-          </a:fontRef>
-        </p:style>
-        <p:txBody>
-          <a:bodyPr rtlCol="0" anchor="ctr"/>
-          <a:lstStyle/>
-          <a:p>
-            <a:pPr algn="ctr"/>
-            <a:endParaRPr kumimoji="1" lang="zh-CN" altLang="en-US"/>
-          </a:p>
-        </p:txBody>
-      </p:sp>
+        </p:spPr>
+      </p:pic>
       <p:pic>
         <p:nvPicPr>
           <p:cNvPr id="7" name="图片 6" descr="电子设备&#10;&#10;描述已自动生成">
@@ -3620,36 +3604,6 @@
           <p:nvPr/>
         </p:nvPicPr>
         <p:blipFill>
-          <a:blip r:embed="rId2"/>
-          <a:stretch>
-            <a:fillRect/>
-          </a:stretch>
-        </p:blipFill>
-        <p:spPr>
-          <a:xfrm>
-            <a:off x="1246796" y="-3747763"/>
-            <a:ext cx="6559693" cy="12829805"/>
-          </a:xfrm>
-          <a:prstGeom prst="rect">
-            <a:avLst/>
-          </a:prstGeom>
-        </p:spPr>
-      </p:pic>
-      <p:pic>
-        <p:nvPicPr>
-          <p:cNvPr id="13" name="图片 12" descr="电子仪器&#10;&#10;描述已自动生成">
-            <a:extLst>
-              <a:ext uri="{FF2B5EF4-FFF2-40B4-BE49-F238E27FC236}">
-                <a16:creationId xmlns:a16="http://schemas.microsoft.com/office/drawing/2014/main" id="{772FAD98-6A88-E570-7965-0B340CADB9C2}"/>
-              </a:ext>
-            </a:extLst>
-          </p:cNvPr>
-          <p:cNvPicPr>
-            <a:picLocks noChangeAspect="1"/>
-          </p:cNvPicPr>
-          <p:nvPr/>
-        </p:nvPicPr>
-        <p:blipFill>
           <a:blip r:embed="rId3"/>
           <a:stretch>
             <a:fillRect/>
@@ -3657,13 +3611,11 @@
         </p:blipFill>
         <p:spPr>
           <a:xfrm>
-            <a:off x="9716222" y="1715407"/>
-            <a:ext cx="6559693" cy="12818942"/>
-          </a:xfrm>
-          <a:prstGeom prst="roundRect">
-            <a:avLst>
-              <a:gd name="adj" fmla="val 7243"/>
-            </a:avLst>
+            <a:off x="1246796" y="-3747763"/>
+            <a:ext cx="6559693" cy="12829805"/>
+          </a:xfrm>
+          <a:prstGeom prst="rect">
+            <a:avLst/>
           </a:prstGeom>
         </p:spPr>
       </p:pic>
@@ -3710,8 +3662,8 @@
         </p:nvSpPr>
         <p:spPr>
           <a:xfrm>
-            <a:off x="20797443" y="2194434"/>
-            <a:ext cx="735646" cy="335800"/>
+            <a:off x="20830466" y="2169780"/>
+            <a:ext cx="678612" cy="335800"/>
           </a:xfrm>
           <a:prstGeom prst="rect">
             <a:avLst/>
@@ -3744,27 +3696,7 @@
           <a:lstStyle/>
           <a:p>
             <a:pPr algn="ctr"/>
-            <a:r>
-              <a:rPr kumimoji="1" lang="zh-CN" altLang="en-US" sz="1600" dirty="0">
-                <a:solidFill>
-                  <a:schemeClr val="bg1">
-                    <a:lumMod val="75000"/>
-                  </a:schemeClr>
-                </a:solidFill>
-              </a:rPr>
-              <a:t>对象</a:t>
-            </a:r>
-            <a:r>
-              <a:rPr kumimoji="1" lang="en-US" altLang="zh-CN" sz="1600" dirty="0">
-                <a:solidFill>
-                  <a:schemeClr val="bg1">
-                    <a:lumMod val="75000"/>
-                  </a:schemeClr>
-                </a:solidFill>
-              </a:rPr>
-              <a:t>X</a:t>
-            </a:r>
-            <a:endParaRPr kumimoji="1" lang="zh-CN" altLang="en-US" sz="1600" dirty="0">
+            <a:endParaRPr kumimoji="1" lang="zh-CN" altLang="en-US" sz="1600" i="1" dirty="0">
               <a:solidFill>
                 <a:schemeClr val="bg1">
                   <a:lumMod val="75000"/>
@@ -3789,7 +3721,7 @@
           <p:nvPr/>
         </p:nvPicPr>
         <p:blipFill>
-          <a:blip r:embed="rId5"/>
+          <a:blip r:embed="rId2"/>
           <a:stretch>
             <a:fillRect/>
           </a:stretch>
@@ -3819,6 +3751,36 @@
           <p:nvPr/>
         </p:nvPicPr>
         <p:blipFill>
+          <a:blip r:embed="rId2"/>
+          <a:stretch>
+            <a:fillRect/>
+          </a:stretch>
+        </p:blipFill>
+        <p:spPr>
+          <a:xfrm>
+            <a:off x="8321090" y="1060575"/>
+            <a:ext cx="9555811" cy="15941741"/>
+          </a:xfrm>
+          <a:prstGeom prst="rect">
+            <a:avLst/>
+          </a:prstGeom>
+        </p:spPr>
+      </p:pic>
+      <p:pic>
+        <p:nvPicPr>
+          <p:cNvPr id="3" name="图片 2" descr="手机的屏幕截图&#10;&#10;描述已自动生成">
+            <a:extLst>
+              <a:ext uri="{FF2B5EF4-FFF2-40B4-BE49-F238E27FC236}">
+                <a16:creationId xmlns:a16="http://schemas.microsoft.com/office/drawing/2014/main" id="{CB046F88-DEE3-3D3E-A7FD-7C1D303601AA}"/>
+              </a:ext>
+            </a:extLst>
+          </p:cNvPr>
+          <p:cNvPicPr>
+            <a:picLocks noChangeAspect="1"/>
+          </p:cNvPicPr>
+          <p:nvPr/>
+        </p:nvPicPr>
+        <p:blipFill>
           <a:blip r:embed="rId5"/>
           <a:stretch>
             <a:fillRect/>
@@ -3826,20 +3788,49 @@
         </p:blipFill>
         <p:spPr>
           <a:xfrm>
-            <a:off x="8321090" y="1060575"/>
-            <a:ext cx="9555811" cy="15941741"/>
+            <a:off x="9629734" y="1373862"/>
+            <a:ext cx="6732670" cy="14590958"/>
           </a:xfrm>
           <a:prstGeom prst="rect">
             <a:avLst/>
           </a:prstGeom>
         </p:spPr>
       </p:pic>
-      <p:sp>
-        <p:nvSpPr>
-          <p:cNvPr id="22" name="矩形 21">
+      <p:pic>
+        <p:nvPicPr>
+          <p:cNvPr id="5" name="图片 4" descr="手机的屏幕截图&#10;&#10;描述已自动生成">
             <a:extLst>
               <a:ext uri="{FF2B5EF4-FFF2-40B4-BE49-F238E27FC236}">
-                <a16:creationId xmlns:a16="http://schemas.microsoft.com/office/drawing/2014/main" id="{ADA20CAA-3F55-943D-C4A2-46A58736A96A}"/>
+                <a16:creationId xmlns:a16="http://schemas.microsoft.com/office/drawing/2014/main" id="{89164A1C-4017-2640-A45F-0B2E6E8A9C3D}"/>
+              </a:ext>
+            </a:extLst>
+          </p:cNvPr>
+          <p:cNvPicPr>
+            <a:picLocks noChangeAspect="1"/>
+          </p:cNvPicPr>
+          <p:nvPr/>
+        </p:nvPicPr>
+        <p:blipFill>
+          <a:blip r:embed="rId5"/>
+          <a:srcRect t="31503"/>
+          <a:stretch/>
+        </p:blipFill>
+        <p:spPr>
+          <a:xfrm>
+            <a:off x="9629734" y="4966447"/>
+            <a:ext cx="6732670" cy="9994326"/>
+          </a:xfrm>
+          <a:prstGeom prst="rect">
+            <a:avLst/>
+          </a:prstGeom>
+        </p:spPr>
+      </p:pic>
+      <p:sp>
+        <p:nvSpPr>
+          <p:cNvPr id="4" name="矩形 3">
+            <a:extLst>
+              <a:ext uri="{FF2B5EF4-FFF2-40B4-BE49-F238E27FC236}">
+                <a16:creationId xmlns:a16="http://schemas.microsoft.com/office/drawing/2014/main" id="{E6149673-AA13-A2AE-AD10-F5C9C58E2AD1}"/>
               </a:ext>
             </a:extLst>
           </p:cNvPr>
@@ -3848,14 +3839,14 @@
         </p:nvSpPr>
         <p:spPr>
           <a:xfrm>
-            <a:off x="20711756" y="3708119"/>
-            <a:ext cx="735646" cy="335800"/>
+            <a:off x="-4446320" y="12204700"/>
+            <a:ext cx="30438458" cy="6896100"/>
           </a:xfrm>
           <a:prstGeom prst="rect">
             <a:avLst/>
           </a:prstGeom>
           <a:solidFill>
-            <a:srgbClr val="0A0A0A"/>
+            <a:srgbClr val="ECECEC"/>
           </a:solidFill>
           <a:ln>
             <a:noFill/>
@@ -3882,11 +3873,480 @@
           <a:lstStyle/>
           <a:p>
             <a:pPr algn="ctr"/>
+            <a:endParaRPr kumimoji="1" lang="zh-CN" altLang="en-US"/>
+          </a:p>
+        </p:txBody>
+      </p:sp>
+      <p:sp>
+        <p:nvSpPr>
+          <p:cNvPr id="6" name="矩形 5">
+            <a:extLst>
+              <a:ext uri="{FF2B5EF4-FFF2-40B4-BE49-F238E27FC236}">
+                <a16:creationId xmlns:a16="http://schemas.microsoft.com/office/drawing/2014/main" id="{71A73D9F-B805-A641-187D-C8B761E826F4}"/>
+              </a:ext>
+            </a:extLst>
+          </p:cNvPr>
+          <p:cNvSpPr/>
+          <p:nvPr/>
+        </p:nvSpPr>
+        <p:spPr>
+          <a:xfrm>
+            <a:off x="20654246" y="2198535"/>
+            <a:ext cx="1009557" cy="335800"/>
+          </a:xfrm>
+          <a:prstGeom prst="rect">
+            <a:avLst/>
+          </a:prstGeom>
+          <a:noFill/>
+          <a:ln>
+            <a:noFill/>
+          </a:ln>
+        </p:spPr>
+        <p:style>
+          <a:lnRef idx="2">
+            <a:schemeClr val="accent1">
+              <a:shade val="15000"/>
+            </a:schemeClr>
+          </a:lnRef>
+          <a:fillRef idx="1">
+            <a:schemeClr val="accent1"/>
+          </a:fillRef>
+          <a:effectRef idx="0">
+            <a:schemeClr val="accent1"/>
+          </a:effectRef>
+          <a:fontRef idx="minor">
+            <a:schemeClr val="lt1"/>
+          </a:fontRef>
+        </p:style>
+        <p:txBody>
+          <a:bodyPr rtlCol="0" anchor="ctr"/>
+          <a:lstStyle/>
+          <a:p>
+            <a:pPr algn="ctr"/>
+            <a:r>
+              <a:rPr kumimoji="1" lang="zh-CN" altLang="en-US" sz="1500" i="1" dirty="0">
+                <a:solidFill>
+                  <a:schemeClr val="bg1">
+                    <a:lumMod val="75000"/>
+                  </a:schemeClr>
+                </a:solidFill>
+                <a:latin typeface="Microsoft YaHei" panose="020B0503020204020204" pitchFamily="34" charset="-122"/>
+                <a:ea typeface="Microsoft YaHei" panose="020B0503020204020204" pitchFamily="34" charset="-122"/>
+              </a:rPr>
+              <a:t>某对象</a:t>
+            </a:r>
+          </a:p>
+        </p:txBody>
+      </p:sp>
+      <p:sp>
+        <p:nvSpPr>
+          <p:cNvPr id="10" name="矩形 9">
+            <a:extLst>
+              <a:ext uri="{FF2B5EF4-FFF2-40B4-BE49-F238E27FC236}">
+                <a16:creationId xmlns:a16="http://schemas.microsoft.com/office/drawing/2014/main" id="{BB3BD6D4-13D6-B15A-0FAE-EB79E6D0C63D}"/>
+              </a:ext>
+            </a:extLst>
+          </p:cNvPr>
+          <p:cNvSpPr/>
+          <p:nvPr/>
+        </p:nvSpPr>
+        <p:spPr>
+          <a:xfrm>
+            <a:off x="20728236" y="3726732"/>
+            <a:ext cx="670731" cy="299932"/>
+          </a:xfrm>
+          <a:prstGeom prst="rect">
+            <a:avLst/>
+          </a:prstGeom>
+          <a:solidFill>
+            <a:srgbClr val="14140F"/>
+          </a:solidFill>
+        </p:spPr>
+        <p:style>
+          <a:lnRef idx="2">
+            <a:schemeClr val="dk1">
+              <a:shade val="15000"/>
+            </a:schemeClr>
+          </a:lnRef>
+          <a:fillRef idx="1">
+            <a:schemeClr val="dk1"/>
+          </a:fillRef>
+          <a:effectRef idx="0">
+            <a:schemeClr val="dk1"/>
+          </a:effectRef>
+          <a:fontRef idx="minor">
+            <a:schemeClr val="lt1"/>
+          </a:fontRef>
+        </p:style>
+        <p:txBody>
+          <a:bodyPr rtlCol="0" anchor="ctr"/>
+          <a:lstStyle/>
+          <a:p>
+            <a:pPr algn="ctr"/>
+            <a:endParaRPr kumimoji="1" lang="zh-CN" altLang="en-US"/>
+          </a:p>
+        </p:txBody>
+      </p:sp>
+      <p:sp>
+        <p:nvSpPr>
+          <p:cNvPr id="9" name="矩形 8">
+            <a:extLst>
+              <a:ext uri="{FF2B5EF4-FFF2-40B4-BE49-F238E27FC236}">
+                <a16:creationId xmlns:a16="http://schemas.microsoft.com/office/drawing/2014/main" id="{128E3B2B-DE8A-3A27-1877-1D15D78DA060}"/>
+              </a:ext>
+            </a:extLst>
+          </p:cNvPr>
+          <p:cNvSpPr/>
+          <p:nvPr/>
+        </p:nvSpPr>
+        <p:spPr>
+          <a:xfrm>
+            <a:off x="20558822" y="3714306"/>
+            <a:ext cx="1009557" cy="335800"/>
+          </a:xfrm>
+          <a:prstGeom prst="rect">
+            <a:avLst/>
+          </a:prstGeom>
+          <a:noFill/>
+          <a:ln>
+            <a:noFill/>
+          </a:ln>
+        </p:spPr>
+        <p:style>
+          <a:lnRef idx="2">
+            <a:schemeClr val="accent1">
+              <a:shade val="15000"/>
+            </a:schemeClr>
+          </a:lnRef>
+          <a:fillRef idx="1">
+            <a:schemeClr val="accent1"/>
+          </a:fillRef>
+          <a:effectRef idx="0">
+            <a:schemeClr val="accent1"/>
+          </a:effectRef>
+          <a:fontRef idx="minor">
+            <a:schemeClr val="lt1"/>
+          </a:fontRef>
+        </p:style>
+        <p:txBody>
+          <a:bodyPr rtlCol="0" anchor="ctr"/>
+          <a:lstStyle/>
+          <a:p>
+            <a:pPr algn="ctr"/>
+            <a:r>
+              <a:rPr kumimoji="1" lang="zh-CN" altLang="en-US" sz="1500" i="1" dirty="0">
+                <a:solidFill>
+                  <a:schemeClr val="bg1">
+                    <a:lumMod val="85000"/>
+                  </a:schemeClr>
+                </a:solidFill>
+                <a:latin typeface="Microsoft YaHei" panose="020B0503020204020204" pitchFamily="34" charset="-122"/>
+                <a:ea typeface="Microsoft YaHei" panose="020B0503020204020204" pitchFamily="34" charset="-122"/>
+              </a:rPr>
+              <a:t>某对象</a:t>
+            </a:r>
+          </a:p>
+        </p:txBody>
+      </p:sp>
+    </p:spTree>
+    <p:extLst>
+      <p:ext uri="{BB962C8B-B14F-4D97-AF65-F5344CB8AC3E}">
+        <p14:creationId xmlns:p14="http://schemas.microsoft.com/office/powerpoint/2010/main" val="2677001212"/>
+      </p:ext>
+    </p:extLst>
+  </p:cSld>
+  <p:clrMapOvr>
+    <a:masterClrMapping/>
+  </p:clrMapOvr>
+</p:sld>
+</file>
+
+<file path=ppt/slides/slide3.xml><?xml version="1.0" encoding="utf-8"?>
+<p:sld xmlns:a="http://schemas.openxmlformats.org/drawingml/2006/main" xmlns:r="http://schemas.openxmlformats.org/officeDocument/2006/relationships" xmlns:p="http://schemas.openxmlformats.org/presentationml/2006/main" show="0">
+  <p:cSld>
+    <p:spTree>
+      <p:nvGrpSpPr>
+        <p:cNvPr id="1" name="">
+          <a:extLst>
+            <a:ext uri="{FF2B5EF4-FFF2-40B4-BE49-F238E27FC236}">
+              <a16:creationId xmlns:a16="http://schemas.microsoft.com/office/drawing/2014/main" id="{B451201A-830C-BC9F-75BE-C5B432287186}"/>
+            </a:ext>
+          </a:extLst>
+        </p:cNvPr>
+        <p:cNvGrpSpPr/>
+        <p:nvPr/>
+      </p:nvGrpSpPr>
+      <p:grpSpPr>
+        <a:xfrm>
+          <a:off x="0" y="0"/>
+          <a:ext cx="0" cy="0"/>
+          <a:chOff x="0" y="0"/>
+          <a:chExt cx="0" cy="0"/>
+        </a:xfrm>
+      </p:grpSpPr>
+      <p:sp>
+        <p:nvSpPr>
+          <p:cNvPr id="25" name="矩形 24">
+            <a:extLst>
+              <a:ext uri="{FF2B5EF4-FFF2-40B4-BE49-F238E27FC236}">
+                <a16:creationId xmlns:a16="http://schemas.microsoft.com/office/drawing/2014/main" id="{E880249E-0207-F69F-2D6B-7A99D5FBFA29}"/>
+              </a:ext>
+            </a:extLst>
+          </p:cNvPr>
+          <p:cNvSpPr/>
+          <p:nvPr/>
+        </p:nvSpPr>
+        <p:spPr>
+          <a:xfrm>
+            <a:off x="0" y="0"/>
+            <a:ext cx="25992138" cy="12204700"/>
+          </a:xfrm>
+          <a:prstGeom prst="rect">
+            <a:avLst/>
+          </a:prstGeom>
+          <a:gradFill>
+            <a:gsLst>
+              <a:gs pos="75000">
+                <a:srgbClr val="D8CA96"/>
+              </a:gs>
+              <a:gs pos="100000">
+                <a:srgbClr val="F2E8A5">
+                  <a:alpha val="50000"/>
+                </a:srgbClr>
+              </a:gs>
+              <a:gs pos="42000">
+                <a:srgbClr val="CBBB8E"/>
+              </a:gs>
+              <a:gs pos="0">
+                <a:srgbClr val="F2E8A5">
+                  <a:alpha val="50000"/>
+                </a:srgbClr>
+              </a:gs>
+            </a:gsLst>
+            <a:lin ang="2700000" scaled="0"/>
+          </a:gradFill>
+        </p:spPr>
+        <p:style>
+          <a:lnRef idx="2">
+            <a:schemeClr val="accent1">
+              <a:shade val="15000"/>
+            </a:schemeClr>
+          </a:lnRef>
+          <a:fillRef idx="1">
+            <a:schemeClr val="accent1"/>
+          </a:fillRef>
+          <a:effectRef idx="0">
+            <a:schemeClr val="accent1"/>
+          </a:effectRef>
+          <a:fontRef idx="minor">
+            <a:schemeClr val="lt1"/>
+          </a:fontRef>
+        </p:style>
+        <p:txBody>
+          <a:bodyPr rtlCol="0" anchor="ctr"/>
+          <a:lstStyle/>
+          <a:p>
+            <a:pPr algn="ctr"/>
+            <a:endParaRPr kumimoji="1" lang="zh-CN" altLang="en-US" dirty="0"/>
+          </a:p>
+        </p:txBody>
+      </p:sp>
+      <p:sp>
+        <p:nvSpPr>
+          <p:cNvPr id="20" name="矩形 19">
+            <a:extLst>
+              <a:ext uri="{FF2B5EF4-FFF2-40B4-BE49-F238E27FC236}">
+                <a16:creationId xmlns:a16="http://schemas.microsoft.com/office/drawing/2014/main" id="{ED9C563E-348F-BE4A-CAB5-FFA2038AD479}"/>
+              </a:ext>
+            </a:extLst>
+          </p:cNvPr>
+          <p:cNvSpPr/>
+          <p:nvPr/>
+        </p:nvSpPr>
+        <p:spPr>
+          <a:xfrm>
+            <a:off x="9620520" y="1455312"/>
+            <a:ext cx="6732670" cy="605307"/>
+          </a:xfrm>
+          <a:prstGeom prst="rect">
+            <a:avLst/>
+          </a:prstGeom>
+          <a:solidFill>
+            <a:srgbClr val="1A1A1A"/>
+          </a:solidFill>
+          <a:ln>
+            <a:noFill/>
+          </a:ln>
+        </p:spPr>
+        <p:style>
+          <a:lnRef idx="2">
+            <a:schemeClr val="accent1">
+              <a:shade val="15000"/>
+            </a:schemeClr>
+          </a:lnRef>
+          <a:fillRef idx="1">
+            <a:schemeClr val="accent1"/>
+          </a:fillRef>
+          <a:effectRef idx="0">
+            <a:schemeClr val="accent1"/>
+          </a:effectRef>
+          <a:fontRef idx="minor">
+            <a:schemeClr val="lt1"/>
+          </a:fontRef>
+        </p:style>
+        <p:txBody>
+          <a:bodyPr rtlCol="0" anchor="ctr"/>
+          <a:lstStyle/>
+          <a:p>
+            <a:pPr algn="ctr"/>
+            <a:endParaRPr kumimoji="1" lang="zh-CN" altLang="en-US"/>
+          </a:p>
+        </p:txBody>
+      </p:sp>
+      <p:pic>
+        <p:nvPicPr>
+          <p:cNvPr id="7" name="图片 6" descr="电子设备&#10;&#10;描述已自动生成">
+            <a:extLst>
+              <a:ext uri="{FF2B5EF4-FFF2-40B4-BE49-F238E27FC236}">
+                <a16:creationId xmlns:a16="http://schemas.microsoft.com/office/drawing/2014/main" id="{8BAAD3F1-ED34-86ED-FB02-88B961C16912}"/>
+              </a:ext>
+            </a:extLst>
+          </p:cNvPr>
+          <p:cNvPicPr>
+            <a:picLocks noChangeAspect="1"/>
+          </p:cNvPicPr>
+          <p:nvPr/>
+        </p:nvPicPr>
+        <p:blipFill>
+          <a:blip r:embed="rId2"/>
+          <a:stretch>
+            <a:fillRect/>
+          </a:stretch>
+        </p:blipFill>
+        <p:spPr>
+          <a:xfrm>
+            <a:off x="1246796" y="-3747763"/>
+            <a:ext cx="6559693" cy="12829805"/>
+          </a:xfrm>
+          <a:prstGeom prst="rect">
+            <a:avLst/>
+          </a:prstGeom>
+        </p:spPr>
+      </p:pic>
+      <p:pic>
+        <p:nvPicPr>
+          <p:cNvPr id="13" name="图片 12" descr="电子仪器&#10;&#10;描述已自动生成">
+            <a:extLst>
+              <a:ext uri="{FF2B5EF4-FFF2-40B4-BE49-F238E27FC236}">
+                <a16:creationId xmlns:a16="http://schemas.microsoft.com/office/drawing/2014/main" id="{0075CB4F-D649-5884-CBC6-7B0F6DC934B7}"/>
+              </a:ext>
+            </a:extLst>
+          </p:cNvPr>
+          <p:cNvPicPr>
+            <a:picLocks noChangeAspect="1"/>
+          </p:cNvPicPr>
+          <p:nvPr/>
+        </p:nvPicPr>
+        <p:blipFill>
+          <a:blip r:embed="rId3"/>
+          <a:stretch>
+            <a:fillRect/>
+          </a:stretch>
+        </p:blipFill>
+        <p:spPr>
+          <a:xfrm>
+            <a:off x="9716222" y="1715407"/>
+            <a:ext cx="6559693" cy="12818942"/>
+          </a:xfrm>
+          <a:prstGeom prst="roundRect">
+            <a:avLst>
+              <a:gd name="adj" fmla="val 7243"/>
+            </a:avLst>
+          </a:prstGeom>
+        </p:spPr>
+      </p:pic>
+      <p:pic>
+        <p:nvPicPr>
+          <p:cNvPr id="15" name="图片 14" descr="电子设备&#10;&#10;描述已自动生成">
+            <a:extLst>
+              <a:ext uri="{FF2B5EF4-FFF2-40B4-BE49-F238E27FC236}">
+                <a16:creationId xmlns:a16="http://schemas.microsoft.com/office/drawing/2014/main" id="{FAFF907F-E9AF-3C19-EF10-A5C9F5D44630}"/>
+              </a:ext>
+            </a:extLst>
+          </p:cNvPr>
+          <p:cNvPicPr>
+            <a:picLocks noChangeAspect="1"/>
+          </p:cNvPicPr>
+          <p:nvPr/>
+        </p:nvPicPr>
+        <p:blipFill>
+          <a:blip r:embed="rId4"/>
+          <a:srcRect l="2441" t="1010" r="2166" b="1635"/>
+          <a:stretch/>
+        </p:blipFill>
+        <p:spPr>
+          <a:xfrm>
+            <a:off x="18101232" y="-3747763"/>
+            <a:ext cx="6595470" cy="12829805"/>
+          </a:xfrm>
+          <a:prstGeom prst="rect">
+            <a:avLst/>
+          </a:prstGeom>
+        </p:spPr>
+      </p:pic>
+      <p:sp>
+        <p:nvSpPr>
+          <p:cNvPr id="16" name="矩形 15">
+            <a:extLst>
+              <a:ext uri="{FF2B5EF4-FFF2-40B4-BE49-F238E27FC236}">
+                <a16:creationId xmlns:a16="http://schemas.microsoft.com/office/drawing/2014/main" id="{5F27B3F6-23E0-34DC-FC87-272C101E8ACC}"/>
+              </a:ext>
+            </a:extLst>
+          </p:cNvPr>
+          <p:cNvSpPr/>
+          <p:nvPr/>
+        </p:nvSpPr>
+        <p:spPr>
+          <a:xfrm>
+            <a:off x="20797443" y="2194434"/>
+            <a:ext cx="735646" cy="335800"/>
+          </a:xfrm>
+          <a:prstGeom prst="rect">
+            <a:avLst/>
+          </a:prstGeom>
+          <a:solidFill>
+            <a:srgbClr val="0A0A0A"/>
+          </a:solidFill>
+          <a:ln>
+            <a:noFill/>
+          </a:ln>
+        </p:spPr>
+        <p:style>
+          <a:lnRef idx="2">
+            <a:schemeClr val="accent1">
+              <a:shade val="15000"/>
+            </a:schemeClr>
+          </a:lnRef>
+          <a:fillRef idx="1">
+            <a:schemeClr val="accent1"/>
+          </a:fillRef>
+          <a:effectRef idx="0">
+            <a:schemeClr val="accent1"/>
+          </a:effectRef>
+          <a:fontRef idx="minor">
+            <a:schemeClr val="lt1"/>
+          </a:fontRef>
+        </p:style>
+        <p:txBody>
+          <a:bodyPr rtlCol="0" anchor="ctr"/>
+          <a:lstStyle/>
+          <a:p>
+            <a:pPr algn="ctr"/>
             <a:r>
               <a:rPr kumimoji="1" lang="zh-CN" altLang="en-US" sz="1600" dirty="0">
                 <a:solidFill>
                   <a:schemeClr val="bg1">
-                    <a:lumMod val="95000"/>
+                    <a:lumMod val="75000"/>
                   </a:schemeClr>
                 </a:solidFill>
               </a:rPr>
@@ -3896,7 +4356,7 @@
               <a:rPr kumimoji="1" lang="en-US" altLang="zh-CN" sz="1600" dirty="0">
                 <a:solidFill>
                   <a:schemeClr val="bg1">
-                    <a:lumMod val="95000"/>
+                    <a:lumMod val="75000"/>
                   </a:schemeClr>
                 </a:solidFill>
               </a:rPr>
@@ -3905,7 +4365,7 @@
             <a:endParaRPr kumimoji="1" lang="zh-CN" altLang="en-US" sz="1600" dirty="0">
               <a:solidFill>
                 <a:schemeClr val="bg1">
-                  <a:lumMod val="95000"/>
+                  <a:lumMod val="75000"/>
                 </a:schemeClr>
               </a:solidFill>
             </a:endParaRPr>
@@ -3914,10 +4374,10 @@
       </p:sp>
       <p:pic>
         <p:nvPicPr>
-          <p:cNvPr id="21" name="图片 20" descr="图片包含 矩形&#10;&#10;描述已自动生成">
+          <p:cNvPr id="18" name="图片 17" descr="图片包含 矩形&#10;&#10;描述已自动生成">
             <a:extLst>
               <a:ext uri="{FF2B5EF4-FFF2-40B4-BE49-F238E27FC236}">
-                <a16:creationId xmlns:a16="http://schemas.microsoft.com/office/drawing/2014/main" id="{E47746B1-7C10-9913-C9E2-FF87F137D4A6}"/>
+                <a16:creationId xmlns:a16="http://schemas.microsoft.com/office/drawing/2014/main" id="{25EF6048-45A5-1039-2DED-EA58AB69477E}"/>
               </a:ext>
             </a:extLst>
           </p:cNvPr>
@@ -3934,6 +4394,144 @@
         </p:blipFill>
         <p:spPr>
           <a:xfrm>
+            <a:off x="-143430" y="-5633190"/>
+            <a:ext cx="9555811" cy="15941741"/>
+          </a:xfrm>
+          <a:prstGeom prst="rect">
+            <a:avLst/>
+          </a:prstGeom>
+        </p:spPr>
+      </p:pic>
+      <p:pic>
+        <p:nvPicPr>
+          <p:cNvPr id="19" name="图片 18" descr="图片包含 矩形&#10;&#10;描述已自动生成">
+            <a:extLst>
+              <a:ext uri="{FF2B5EF4-FFF2-40B4-BE49-F238E27FC236}">
+                <a16:creationId xmlns:a16="http://schemas.microsoft.com/office/drawing/2014/main" id="{B51CEF11-9BE0-4084-F954-74E2EF57B95D}"/>
+              </a:ext>
+            </a:extLst>
+          </p:cNvPr>
+          <p:cNvPicPr>
+            <a:picLocks noChangeAspect="1"/>
+          </p:cNvPicPr>
+          <p:nvPr/>
+        </p:nvPicPr>
+        <p:blipFill>
+          <a:blip r:embed="rId5"/>
+          <a:stretch>
+            <a:fillRect/>
+          </a:stretch>
+        </p:blipFill>
+        <p:spPr>
+          <a:xfrm>
+            <a:off x="8321090" y="1060575"/>
+            <a:ext cx="9555811" cy="15941741"/>
+          </a:xfrm>
+          <a:prstGeom prst="rect">
+            <a:avLst/>
+          </a:prstGeom>
+        </p:spPr>
+      </p:pic>
+      <p:sp>
+        <p:nvSpPr>
+          <p:cNvPr id="22" name="矩形 21">
+            <a:extLst>
+              <a:ext uri="{FF2B5EF4-FFF2-40B4-BE49-F238E27FC236}">
+                <a16:creationId xmlns:a16="http://schemas.microsoft.com/office/drawing/2014/main" id="{0D53CFFA-89F9-A95E-57C7-439926E685D4}"/>
+              </a:ext>
+            </a:extLst>
+          </p:cNvPr>
+          <p:cNvSpPr/>
+          <p:nvPr/>
+        </p:nvSpPr>
+        <p:spPr>
+          <a:xfrm>
+            <a:off x="20711756" y="3708119"/>
+            <a:ext cx="735646" cy="335800"/>
+          </a:xfrm>
+          <a:prstGeom prst="rect">
+            <a:avLst/>
+          </a:prstGeom>
+          <a:solidFill>
+            <a:srgbClr val="0A0A0A"/>
+          </a:solidFill>
+          <a:ln>
+            <a:noFill/>
+          </a:ln>
+        </p:spPr>
+        <p:style>
+          <a:lnRef idx="2">
+            <a:schemeClr val="accent1">
+              <a:shade val="15000"/>
+            </a:schemeClr>
+          </a:lnRef>
+          <a:fillRef idx="1">
+            <a:schemeClr val="accent1"/>
+          </a:fillRef>
+          <a:effectRef idx="0">
+            <a:schemeClr val="accent1"/>
+          </a:effectRef>
+          <a:fontRef idx="minor">
+            <a:schemeClr val="lt1"/>
+          </a:fontRef>
+        </p:style>
+        <p:txBody>
+          <a:bodyPr rtlCol="0" anchor="ctr"/>
+          <a:lstStyle/>
+          <a:p>
+            <a:pPr algn="ctr"/>
+            <a:r>
+              <a:rPr kumimoji="1" lang="zh-CN" altLang="en-US" sz="1600" dirty="0">
+                <a:solidFill>
+                  <a:schemeClr val="bg1">
+                    <a:lumMod val="95000"/>
+                  </a:schemeClr>
+                </a:solidFill>
+              </a:rPr>
+              <a:t>对象</a:t>
+            </a:r>
+            <a:r>
+              <a:rPr kumimoji="1" lang="en-US" altLang="zh-CN" sz="1600" dirty="0">
+                <a:solidFill>
+                  <a:schemeClr val="bg1">
+                    <a:lumMod val="95000"/>
+                  </a:schemeClr>
+                </a:solidFill>
+              </a:rPr>
+              <a:t>X</a:t>
+            </a:r>
+            <a:endParaRPr kumimoji="1" lang="zh-CN" altLang="en-US" sz="1600" dirty="0">
+              <a:solidFill>
+                <a:schemeClr val="bg1">
+                  <a:lumMod val="95000"/>
+                </a:schemeClr>
+              </a:solidFill>
+            </a:endParaRPr>
+          </a:p>
+        </p:txBody>
+      </p:sp>
+      <p:pic>
+        <p:nvPicPr>
+          <p:cNvPr id="21" name="图片 20" descr="图片包含 矩形&#10;&#10;描述已自动生成">
+            <a:extLst>
+              <a:ext uri="{FF2B5EF4-FFF2-40B4-BE49-F238E27FC236}">
+                <a16:creationId xmlns:a16="http://schemas.microsoft.com/office/drawing/2014/main" id="{0C7D4487-3309-9EBB-63CC-FFF4D38C24DD}"/>
+              </a:ext>
+            </a:extLst>
+          </p:cNvPr>
+          <p:cNvPicPr>
+            <a:picLocks noChangeAspect="1"/>
+          </p:cNvPicPr>
+          <p:nvPr/>
+        </p:nvPicPr>
+        <p:blipFill>
+          <a:blip r:embed="rId5"/>
+          <a:stretch>
+            <a:fillRect/>
+          </a:stretch>
+        </p:blipFill>
+        <p:spPr>
+          <a:xfrm>
             <a:off x="16731173" y="-5633190"/>
             <a:ext cx="9555811" cy="15941741"/>
           </a:xfrm>
@@ -3945,7 +4543,7 @@
     </p:spTree>
     <p:extLst>
       <p:ext uri="{BB962C8B-B14F-4D97-AF65-F5344CB8AC3E}">
-        <p14:creationId xmlns:p14="http://schemas.microsoft.com/office/powerpoint/2010/main" val="2677001212"/>
+        <p14:creationId xmlns:p14="http://schemas.microsoft.com/office/powerpoint/2010/main" val="4225575542"/>
       </p:ext>
     </p:extLst>
   </p:cSld>

</xml_diff>